<commit_message>
Add benchmarking reports baselines
</commit_message>
<xml_diff>
--- a/Documentation/Figures/Latency and Response Time.pptx
+++ b/Documentation/Figures/Latency and Response Time.pptx
@@ -259,7 +259,7 @@
           <a:p>
             <a:fld id="{2231E127-0FFC-443A-B14E-CEAC92C6D946}" type="datetimeFigureOut">
               <a:rPr lang="en-US" smtClean="0"/>
-              <a:t>3/27/23</a:t>
+              <a:t>4/3/2023</a:t>
             </a:fld>
             <a:endParaRPr lang="en-US"/>
           </a:p>
@@ -457,7 +457,7 @@
           <a:p>
             <a:fld id="{2231E127-0FFC-443A-B14E-CEAC92C6D946}" type="datetimeFigureOut">
               <a:rPr lang="en-US" smtClean="0"/>
-              <a:t>3/27/23</a:t>
+              <a:t>4/3/2023</a:t>
             </a:fld>
             <a:endParaRPr lang="en-US"/>
           </a:p>
@@ -665,7 +665,7 @@
           <a:p>
             <a:fld id="{2231E127-0FFC-443A-B14E-CEAC92C6D946}" type="datetimeFigureOut">
               <a:rPr lang="en-US" smtClean="0"/>
-              <a:t>3/27/23</a:t>
+              <a:t>4/3/2023</a:t>
             </a:fld>
             <a:endParaRPr lang="en-US"/>
           </a:p>
@@ -863,7 +863,7 @@
           <a:p>
             <a:fld id="{2231E127-0FFC-443A-B14E-CEAC92C6D946}" type="datetimeFigureOut">
               <a:rPr lang="en-US" smtClean="0"/>
-              <a:t>3/27/23</a:t>
+              <a:t>4/3/2023</a:t>
             </a:fld>
             <a:endParaRPr lang="en-US"/>
           </a:p>
@@ -1138,7 +1138,7 @@
           <a:p>
             <a:fld id="{2231E127-0FFC-443A-B14E-CEAC92C6D946}" type="datetimeFigureOut">
               <a:rPr lang="en-US" smtClean="0"/>
-              <a:t>3/27/23</a:t>
+              <a:t>4/3/2023</a:t>
             </a:fld>
             <a:endParaRPr lang="en-US"/>
           </a:p>
@@ -1403,7 +1403,7 @@
           <a:p>
             <a:fld id="{2231E127-0FFC-443A-B14E-CEAC92C6D946}" type="datetimeFigureOut">
               <a:rPr lang="en-US" smtClean="0"/>
-              <a:t>3/27/23</a:t>
+              <a:t>4/3/2023</a:t>
             </a:fld>
             <a:endParaRPr lang="en-US"/>
           </a:p>
@@ -1815,7 +1815,7 @@
           <a:p>
             <a:fld id="{2231E127-0FFC-443A-B14E-CEAC92C6D946}" type="datetimeFigureOut">
               <a:rPr lang="en-US" smtClean="0"/>
-              <a:t>3/27/23</a:t>
+              <a:t>4/3/2023</a:t>
             </a:fld>
             <a:endParaRPr lang="en-US"/>
           </a:p>
@@ -1956,7 +1956,7 @@
           <a:p>
             <a:fld id="{2231E127-0FFC-443A-B14E-CEAC92C6D946}" type="datetimeFigureOut">
               <a:rPr lang="en-US" smtClean="0"/>
-              <a:t>3/27/23</a:t>
+              <a:t>4/3/2023</a:t>
             </a:fld>
             <a:endParaRPr lang="en-US"/>
           </a:p>
@@ -2069,7 +2069,7 @@
           <a:p>
             <a:fld id="{2231E127-0FFC-443A-B14E-CEAC92C6D946}" type="datetimeFigureOut">
               <a:rPr lang="en-US" smtClean="0"/>
-              <a:t>3/27/23</a:t>
+              <a:t>4/3/2023</a:t>
             </a:fld>
             <a:endParaRPr lang="en-US"/>
           </a:p>
@@ -2380,7 +2380,7 @@
           <a:p>
             <a:fld id="{2231E127-0FFC-443A-B14E-CEAC92C6D946}" type="datetimeFigureOut">
               <a:rPr lang="en-US" smtClean="0"/>
-              <a:t>3/27/23</a:t>
+              <a:t>4/3/2023</a:t>
             </a:fld>
             <a:endParaRPr lang="en-US"/>
           </a:p>
@@ -2668,7 +2668,7 @@
           <a:p>
             <a:fld id="{2231E127-0FFC-443A-B14E-CEAC92C6D946}" type="datetimeFigureOut">
               <a:rPr lang="en-US" smtClean="0"/>
-              <a:t>3/27/23</a:t>
+              <a:t>4/3/2023</a:t>
             </a:fld>
             <a:endParaRPr lang="en-US"/>
           </a:p>
@@ -2909,7 +2909,7 @@
           <a:p>
             <a:fld id="{2231E127-0FFC-443A-B14E-CEAC92C6D946}" type="datetimeFigureOut">
               <a:rPr lang="en-US" smtClean="0"/>
-              <a:t>3/27/23</a:t>
+              <a:t>4/3/2023</a:t>
             </a:fld>
             <a:endParaRPr lang="en-US"/>
           </a:p>
@@ -4587,7 +4587,7 @@
         </p:nvCxnSpPr>
         <p:spPr>
           <a:xfrm>
-            <a:off x="3965607" y="3345171"/>
+            <a:off x="3959591" y="3345171"/>
             <a:ext cx="0" cy="3229285"/>
           </a:xfrm>
           <a:prstGeom prst="line">
@@ -4806,20 +4806,25 @@
             <a:prstGeom prst="straightConnector1">
               <a:avLst/>
             </a:prstGeom>
-            <a:ln w="28575">
-              <a:headEnd type="triangle"/>
-              <a:tailEnd type="triangle"/>
+            <a:ln w="28575" cap="flat" cmpd="sng" algn="ctr">
+              <a:solidFill>
+                <a:schemeClr val="dk1"/>
+              </a:solidFill>
+              <a:prstDash val="solid"/>
+              <a:round/>
+              <a:headEnd type="none" w="med" len="med"/>
+              <a:tailEnd type="triangle" w="med" len="med"/>
             </a:ln>
           </p:spPr>
           <p:style>
-            <a:lnRef idx="3">
-              <a:schemeClr val="dk1"/>
+            <a:lnRef idx="0">
+              <a:scrgbClr r="0" g="0" b="0"/>
             </a:lnRef>
             <a:fillRef idx="0">
-              <a:schemeClr val="dk1"/>
+              <a:scrgbClr r="0" g="0" b="0"/>
             </a:fillRef>
-            <a:effectRef idx="2">
-              <a:schemeClr val="dk1"/>
+            <a:effectRef idx="0">
+              <a:scrgbClr r="0" g="0" b="0"/>
             </a:effectRef>
             <a:fontRef idx="minor">
               <a:schemeClr val="tx1"/>
@@ -4879,7 +4884,7 @@
         </p:nvCxnSpPr>
         <p:spPr>
           <a:xfrm>
-            <a:off x="7800328" y="1712013"/>
+            <a:off x="7800328" y="1844365"/>
             <a:ext cx="6448" cy="3072347"/>
           </a:xfrm>
           <a:prstGeom prst="line">
@@ -5009,6 +5014,53 @@
           </p:txBody>
         </p:sp>
       </p:grpSp>
+      <p:cxnSp>
+        <p:nvCxnSpPr>
+          <p:cNvPr id="5" name="Straight Arrow Connector 4">
+            <a:extLst>
+              <a:ext uri="{FF2B5EF4-FFF2-40B4-BE49-F238E27FC236}">
+                <a16:creationId xmlns:a16="http://schemas.microsoft.com/office/drawing/2014/main" id="{BDC5FAB4-2D4A-C9FE-9BE0-AA3007943EE1}"/>
+              </a:ext>
+            </a:extLst>
+          </p:cNvPr>
+          <p:cNvCxnSpPr>
+            <a:cxnSpLocks/>
+          </p:cNvCxnSpPr>
+          <p:nvPr/>
+        </p:nvCxnSpPr>
+        <p:spPr>
+          <a:xfrm flipH="1">
+            <a:off x="7793466" y="4807992"/>
+            <a:ext cx="2154370" cy="0"/>
+          </a:xfrm>
+          <a:prstGeom prst="straightConnector1">
+            <a:avLst/>
+          </a:prstGeom>
+          <a:ln w="28575" cap="flat" cmpd="sng" algn="ctr">
+            <a:solidFill>
+              <a:schemeClr val="dk1"/>
+            </a:solidFill>
+            <a:prstDash val="solid"/>
+            <a:round/>
+            <a:headEnd type="none" w="med" len="med"/>
+            <a:tailEnd type="triangle" w="med" len="med"/>
+          </a:ln>
+        </p:spPr>
+        <p:style>
+          <a:lnRef idx="0">
+            <a:scrgbClr r="0" g="0" b="0"/>
+          </a:lnRef>
+          <a:fillRef idx="0">
+            <a:scrgbClr r="0" g="0" b="0"/>
+          </a:fillRef>
+          <a:effectRef idx="0">
+            <a:scrgbClr r="0" g="0" b="0"/>
+          </a:effectRef>
+          <a:fontRef idx="minor">
+            <a:schemeClr val="tx1"/>
+          </a:fontRef>
+        </p:style>
+      </p:cxnSp>
     </p:spTree>
     <p:extLst>
       <p:ext uri="{BB962C8B-B14F-4D97-AF65-F5344CB8AC3E}">

</xml_diff>